<commit_message>
Add speaker notes, layout fixes, and forward reference to v2 PPTX
- Speaker notes added to all 10 slides with teaching cues, discussion
  questions, and historiographical context for the presenter
- Layout: cap timeline text width (SW*0.38) to maintain right safe zone
- Layout: widen right margin on slide 05 station notes (SW - cx - 0.95)
- Layout: narrow slide 08 event text to prevent overflow (SW - cx - 2.5)
- Slide 07: shift footer up, split into italic quote + amber forward
  reference ("→ Folie VII: 55 Jahre später wird das Christentum Staatsreligion")

https://claude.ai/code/session_013TBMzPSrUf2jGzKeLXb52a
</commit_message>
<xml_diff>
--- a/Anfaenge_Kirche_Antike_v2.pptx
+++ b/Anfaenge_Kirche_Antike_v2.pptx
@@ -511,7 +511,10 @@
           <a:p>
             <a:r>
               <a:rPr lang="en-US" dirty="0"/>
-              <a:t/>
+              <a:t>EINSTIEG (2–3 Min.)
+• Einstiegsfrage: "Was wisst ihr über das frühe Christentum?" — Antworten sammeln.
+• Kontext: Im Jahr 30 n. Chr. war Christentum eine winzige jüdische Randgruppe. 350 Jahre später: Staatsreligion des Römischen Reiches.
+• Die drei Daten auf der Folie (30 / 313 / 380) sind die drei Akte der Geschichte — durch die Präsentation führen wir euch Schritt für Schritt durch.</a:t>
             </a:r>
             <a:endParaRPr lang="en-US" dirty="0"/>
           </a:p>
@@ -599,7 +602,12 @@
           <a:p>
             <a:r>
               <a:rPr lang="en-US" dirty="0"/>
-              <a:t/>
+              <a:t>ABSCHLUSSDISKUSSION (5–10 Min.)
+• Stille lassen. Die Frage wirken lassen — mindestens 5 Sekunden Pause.
+• Mögliche Einstiegsfragen: "Gibt es heute Menschen, die für ihre Überzeugungen sterben?" (Whistleblower, Aktivisten, Soldaten)
+• "Was unterscheidet 'Wofür man stirbt' von 'Wofür man lebt'?"
+• Rückkopplung: "Was hätten die frühen Christen über uns 2026 gedacht?"
+• Bewertungshinweis: Keine richtigen/falschen Antworten. Ziel ist reflektiertes Denken über Werte und Überzeugungen.</a:t>
             </a:r>
             <a:endParaRPr lang="en-US" dirty="0"/>
           </a:p>
@@ -687,7 +695,10 @@
           <a:p>
             <a:r>
               <a:rPr lang="en-US" dirty="0"/>
-              <a:t/>
+              <a:t>KONTEXT — DIE ANTIKE WELT (3–4 Min.)
+• Wichtig: Polytheismus war NORMAL. Es waren die Christen, die als seltsam galten.
+• Frage an Klasse: "Kennt ihr moderne Beispiele von Staatsreligion?" (Iran, Saudi-Arabien, historisch England).
+• Betonung: Persönlicher Glaube als private Gewissenssache — diese Idee ist 2.000 Jahre alt und stammt aus dem Christentum.</a:t>
             </a:r>
             <a:endParaRPr lang="en-US" dirty="0"/>
           </a:p>
@@ -775,7 +786,10 @@
           <a:p>
             <a:r>
               <a:rPr lang="en-US" dirty="0"/>
-              <a:t/>
+              <a:t>GRIECHENLAND — GRUNDLAGE (3 Min.)
+• Die Pointe: Das Christentum konnte sich nur deshalb so schnell ausbreiten, weil Alexander 300 Jahre früher die Infrastruktur geschaffen hatte.
+• Konkret: Paulus brauchte keinen Dolmetscher. Er sprach Griechisch, alle verstanden ihn.
+• Interessant: Das NT ist auf Griechisch — nicht auf Aramäisch (Jesu Muttersprache) oder Hebräisch (Sprache der Bibel).</a:t>
             </a:r>
             <a:endParaRPr lang="en-US" dirty="0"/>
           </a:p>
@@ -863,7 +877,10 @@
           <a:p>
             <a:r>
               <a:rPr lang="en-US" dirty="0"/>
-              <a:t/>
+              <a:t>DIE GEBURT — DIE ERSTE GEMEINDE (4 Min.)
+• Historischer Kern: Die Kreuzigung Jesu ist historisch gut belegt (Tacitus, Josephus). Die Auferstehung ist Glaubensfrage — als Historiker können wir nur sagen: etwas hat die Jünger so überzeugt, dass sie dafür ihr Leben riskierten.
+• Diskussionsfrage: "Was würde euch so überzeugen, dass ihr alles aufgebt?"
+• Die frühen Christen lebten in Gütergemeinschaft — radikales soziales Experiment.</a:t>
             </a:r>
             <a:endParaRPr lang="en-US" dirty="0"/>
           </a:p>
@@ -951,7 +968,11 @@
           <a:p>
             <a:r>
               <a:rPr lang="en-US" dirty="0"/>
-              <a:t/>
+              <a:t>PAULUS — DER ARCHITEKT (3–4 Min.)
+• Pointe: Paulus hat nie Jesus persönlich getroffen — trotzdem schrieb er fast die Hälfte des NT.
+• Sein Brief an die Römer (ca. 57 n. Chr.) ist das älteste systematische Glaubensdokument des Christentums.
+• Areopag-Rede in Athen (Apg 17): Musterstück der Inkulturation — er zitiert griechische Dichter, um Griechen zu erreichen.
+• Historiographisch: Ohne Paulus wäre Christentum möglicherweise eine jüdische Sekte geblieben.</a:t>
             </a:r>
             <a:endParaRPr lang="en-US" dirty="0"/>
           </a:p>
@@ -1039,7 +1060,12 @@
           <a:p>
             <a:r>
               <a:rPr lang="en-US" dirty="0"/>
-              <a:t/>
+              <a:t>VERFOLGUNG — WARUM SCHEITERTE ROM? (3–4 Min.)
+• Tertullian-Zitat ist ein Schlüsselsatz: Märtyrer wirkten als lebende Werbung. Wer stirbt, ohne zu widerrufen, muss etwas Echtes glauben.
+• Nero-Verfolgung: Relativ begrenzt, lokal auf Rom. Aber Petrus und Paulus starben dort.
+• Diokletian-Verfolgung: Die härteste — und nur 10 Jahre vor Konstantins Wende. Fast zu spät.
+• Frage: "Warum kann man eine Idee nicht mit Gewalt töten?"
+• Historiographische Debatte: Wie viele Christen starben wirklich? Zahlen sind umstritten.</a:t>
             </a:r>
             <a:endParaRPr lang="en-US" dirty="0"/>
           </a:p>
@@ -1127,7 +1153,12 @@
           <a:p>
             <a:r>
               <a:rPr lang="en-US" dirty="0"/>
-              <a:t/>
+              <a:t>KONSTANTIN — WENDEPUNKT (4 Min.)
+• WICHTIG: Ob Konstantin wirklich Christ wurde oder ob es politisches Kalkül war, ist bis heute umstritten.
+• Argument für echt: Er bewahrte den Glauben bis zum Lebensende, ließ sich kurz vor dem Tod taufen.
+• Argument für politisch: Das Christentum war die am schnellsten wachsende Religion — gute Wette.
+• Konzil von Nicäa (325): Hier entstand das Nizänische Glaubensbekenntnis — bis heute in katholischen/evangelischen Gottesdiensten.
+• BRÜCKE zu Folie 8: "Konstantin öffnet die Tür — aber was passiert, wenn die Kirche durch diese Tür geht?"</a:t>
             </a:r>
             <a:endParaRPr lang="en-US" dirty="0"/>
           </a:p>
@@ -1215,7 +1246,12 @@
           <a:p>
             <a:r>
               <a:rPr lang="en-US" dirty="0"/>
-              <a:t/>
+              <a:t>DIE WENDE — OPFER WERDEN TÄTER (4 Min.)
+• Das ist die unbequeme Wahrheit der Kirchengeschichte — und die wichtigste Lektion.
+• Hypatia (415): Erste bekannte weibliche Mathematikerin und Philosophin der Antike, von christlichem Mob getötet. Symbol für den Konflikt.
+• Olympische Spiele: Verboten wegen Zeus-Kult — erst 1896 wiederbelebt.
+• Diskussionsfrage: "Liegt es in der Natur jeder Macht, andere zu unterdrücken — oder hätte die Kirche es anders machen können?"
+• Verbindung zu heute: Religionsfreiheit als Grundrecht ist direkte Reaktion auf diese Geschichte.</a:t>
             </a:r>
             <a:endParaRPr lang="en-US" dirty="0"/>
           </a:p>
@@ -1303,7 +1339,12 @@
           <a:p>
             <a:r>
               <a:rPr lang="en-US" dirty="0"/>
-              <a:t/>
+              <a:t>ERBE — WAS BLEIBT (3 Min.)
+• Interaktiv: Für jeden Punkt fragen, ob den Schülern das bewusst war.
+• Sonntag: Kaiser Konstantin 321 n. Chr. — Vorher war Sonntag ein normaler Arbeitstag.
+• Krankenhäuser: Das erste Krankenhaus der Geschichte gründete ein Bischof (Basilius von Cäsarea, ~370 n. Chr.).
+• Universitäten: Viele der ältesten Universitäten (Bologna, Oxford, Paris) aus Klosterschulen entstanden.
+• Ethik: "Menschenwürde gilt für alle" — in der antiken Welt galt das explizit nicht für Sklaven.</a:t>
             </a:r>
             <a:endParaRPr lang="en-US" dirty="0"/>
           </a:p>
@@ -5686,7 +5727,7 @@
         <p:spPr>
           <a:xfrm>
             <a:off x="6970618" y="950976"/>
-            <a:ext cx="5120512" cy="411480"/>
+            <a:ext cx="4632844" cy="411480"/>
           </a:xfrm>
           <a:prstGeom prst="rect">
             <a:avLst/>
@@ -5817,7 +5858,7 @@
         <p:spPr>
           <a:xfrm>
             <a:off x="6970618" y="2048256"/>
-            <a:ext cx="5120512" cy="411480"/>
+            <a:ext cx="4632844" cy="411480"/>
           </a:xfrm>
           <a:prstGeom prst="rect">
             <a:avLst/>
@@ -5948,7 +5989,7 @@
         <p:spPr>
           <a:xfrm>
             <a:off x="6970618" y="3145536"/>
-            <a:ext cx="5120512" cy="411480"/>
+            <a:ext cx="4632844" cy="411480"/>
           </a:xfrm>
           <a:prstGeom prst="rect">
             <a:avLst/>
@@ -6079,7 +6120,7 @@
         <p:spPr>
           <a:xfrm>
             <a:off x="6970618" y="4242816"/>
-            <a:ext cx="5120512" cy="411480"/>
+            <a:ext cx="4632844" cy="411480"/>
           </a:xfrm>
           <a:prstGeom prst="rect">
             <a:avLst/>
@@ -6187,7 +6228,7 @@
         <p:spPr>
           <a:xfrm>
             <a:off x="6970618" y="5340096"/>
-            <a:ext cx="5120512" cy="411480"/>
+            <a:ext cx="4632844" cy="411480"/>
           </a:xfrm>
           <a:prstGeom prst="rect">
             <a:avLst/>
@@ -6868,7 +6909,7 @@
         <p:spPr>
           <a:xfrm>
             <a:off x="6598768" y="978408"/>
-            <a:ext cx="5501488" cy="685800"/>
+            <a:ext cx="5227168" cy="685800"/>
           </a:xfrm>
           <a:prstGeom prst="rect">
             <a:avLst/>
@@ -7002,7 +7043,7 @@
         <p:spPr>
           <a:xfrm>
             <a:off x="6598768" y="2093976"/>
-            <a:ext cx="5501488" cy="685800"/>
+            <a:ext cx="5227168" cy="685800"/>
           </a:xfrm>
           <a:prstGeom prst="rect">
             <a:avLst/>
@@ -7136,7 +7177,7 @@
         <p:spPr>
           <a:xfrm>
             <a:off x="6598768" y="3209544"/>
-            <a:ext cx="5501488" cy="685800"/>
+            <a:ext cx="5227168" cy="685800"/>
           </a:xfrm>
           <a:prstGeom prst="rect">
             <a:avLst/>
@@ -7270,7 +7311,7 @@
         <p:spPr>
           <a:xfrm>
             <a:off x="6598768" y="4325112"/>
-            <a:ext cx="5501488" cy="685800"/>
+            <a:ext cx="5227168" cy="685800"/>
           </a:xfrm>
           <a:prstGeom prst="rect">
             <a:avLst/>
@@ -7381,7 +7422,7 @@
         <p:spPr>
           <a:xfrm>
             <a:off x="6598768" y="5440680"/>
-            <a:ext cx="5501488" cy="685800"/>
+            <a:ext cx="5227168" cy="685800"/>
           </a:xfrm>
           <a:prstGeom prst="rect">
             <a:avLst/>
@@ -9837,7 +9878,7 @@
         </p:blipFill>
         <p:spPr>
           <a:xfrm>
-            <a:off x="274320" y="6455664"/>
+            <a:off x="274320" y="6345936"/>
             <a:ext cx="11643055" cy="18288"/>
           </a:xfrm>
           <a:prstGeom prst="rect">
@@ -9853,8 +9894,8 @@
         </p:nvSpPr>
         <p:spPr>
           <a:xfrm>
-            <a:off x="0" y="6492240"/>
-            <a:ext cx="12191695" cy="292608"/>
+            <a:off x="0" y="6382512"/>
+            <a:ext cx="7924602" cy="274320"/>
           </a:xfrm>
           <a:prstGeom prst="rect">
             <a:avLst/>
@@ -9881,6 +9922,45 @@
               <a:t>Die Verfolgten sitzen jetzt am Tisch des Kaisers.</a:t>
             </a:r>
             <a:endParaRPr lang="en-US" sz="1300" dirty="0"/>
+          </a:p>
+        </p:txBody>
+      </p:sp>
+      <p:sp>
+        <p:nvSpPr>
+          <p:cNvPr id="35" name="Text 23"/>
+          <p:cNvSpPr/>
+          <p:nvPr/>
+        </p:nvSpPr>
+        <p:spPr>
+          <a:xfrm>
+            <a:off x="4267093" y="6382512"/>
+            <a:ext cx="7558851" cy="274320"/>
+          </a:xfrm>
+          <a:prstGeom prst="rect">
+            <a:avLst/>
+          </a:prstGeom>
+          <a:noFill/>
+          <a:ln/>
+        </p:spPr>
+        <p:txBody>
+          <a:bodyPr wrap="square" rtlCol="0" anchor="ctr"/>
+          <a:lstStyle/>
+          <a:p>
+            <a:pPr algn="r" indent="0" marL="0">
+              <a:buNone/>
+            </a:pPr>
+            <a:r>
+              <a:rPr lang="en-US" sz="1100" i="1" dirty="0">
+                <a:solidFill>
+                  <a:srgbClr val="C8820A"/>
+                </a:solidFill>
+                <a:latin typeface="Calibri" pitchFamily="34" charset="0"/>
+                <a:ea typeface="Calibri" pitchFamily="34" charset="-122"/>
+                <a:cs typeface="Calibri" pitchFamily="34" charset="-120"/>
+              </a:rPr>
+              <a:t>→ Folie VII: 55 Jahre später wird das Christentum Staatsreligion.</a:t>
+            </a:r>
+            <a:endParaRPr lang="en-US" sz="1100" dirty="0"/>
           </a:p>
         </p:txBody>
       </p:sp>
@@ -10567,7 +10647,7 @@
         <p:spPr>
           <a:xfrm>
             <a:off x="8363550" y="676656"/>
-            <a:ext cx="3718417" cy="777240"/>
+            <a:ext cx="3444097" cy="777240"/>
           </a:xfrm>
           <a:prstGeom prst="rect">
             <a:avLst/>
@@ -10701,7 +10781,7 @@
         <p:spPr>
           <a:xfrm>
             <a:off x="8363550" y="1545336"/>
-            <a:ext cx="3718417" cy="777240"/>
+            <a:ext cx="3444097" cy="777240"/>
           </a:xfrm>
           <a:prstGeom prst="rect">
             <a:avLst/>
@@ -10835,7 +10915,7 @@
         <p:spPr>
           <a:xfrm>
             <a:off x="8363550" y="2414016"/>
-            <a:ext cx="3718417" cy="777240"/>
+            <a:ext cx="3444097" cy="777240"/>
           </a:xfrm>
           <a:prstGeom prst="rect">
             <a:avLst/>
@@ -10969,7 +11049,7 @@
         <p:spPr>
           <a:xfrm>
             <a:off x="8363550" y="3282696"/>
-            <a:ext cx="3718417" cy="777240"/>
+            <a:ext cx="3444097" cy="777240"/>
           </a:xfrm>
           <a:prstGeom prst="rect">
             <a:avLst/>
@@ -11103,7 +11183,7 @@
         <p:spPr>
           <a:xfrm>
             <a:off x="8363550" y="4151376"/>
-            <a:ext cx="3718417" cy="777240"/>
+            <a:ext cx="3444097" cy="777240"/>
           </a:xfrm>
           <a:prstGeom prst="rect">
             <a:avLst/>
@@ -11237,7 +11317,7 @@
         <p:spPr>
           <a:xfrm>
             <a:off x="8363550" y="5020056"/>
-            <a:ext cx="3718417" cy="777240"/>
+            <a:ext cx="3444097" cy="777240"/>
           </a:xfrm>
           <a:prstGeom prst="rect">
             <a:avLst/>
@@ -11348,7 +11428,7 @@
         <p:spPr>
           <a:xfrm>
             <a:off x="8363550" y="5888736"/>
-            <a:ext cx="3718417" cy="777240"/>
+            <a:ext cx="3444097" cy="777240"/>
           </a:xfrm>
           <a:prstGeom prst="rect">
             <a:avLst/>

</xml_diff>